<commit_message>
slides: add confusion matrix slides to met variants PPT
Two new slides (8 and 9 of 10):
- Slide 8: 4 classifiers × Dy08/Dy24/Dy30 aggregated CM grid (met_nan)
- Slide 9: LogReg × 3 malate variants at Dy30 CM comparison

Co-Authored-By: Claude Sonnet 4.6 <noreply@anthropic.com>
</commit_message>
<xml_diff>
--- a/figures/met_variants_analysis.pptx
+++ b/figures/met_variants_analysis.pptx
@@ -13,6 +13,8 @@
     <p:sldId id="261" r:id="rId12"/>
     <p:sldId id="262" r:id="rId13"/>
     <p:sldId id="263" r:id="rId14"/>
+    <p:sldId id="264" r:id="rId15"/>
+    <p:sldId id="265" r:id="rId16"/>
   </p:sldIdLst>
   <p:sldSz cx="12188952" cy="6858000" type="screen4x3"/>
   <p:notesSz cx="6858000" cy="9144000"/>
@@ -3213,531 +3215,7 @@
 </p:sld>
 </file>
 
-<file path=ppt/slides/slide2.xml><?xml version="1.0" encoding="utf-8"?>
-<p:sld xmlns:a="http://schemas.openxmlformats.org/drawingml/2006/main" xmlns:p="http://schemas.openxmlformats.org/presentationml/2006/main" xmlns:r="http://schemas.openxmlformats.org/officeDocument/2006/relationships">
-  <p:cSld>
-    <p:spTree>
-      <p:nvGrpSpPr>
-        <p:cNvPr id="1" name=""/>
-        <p:cNvGrpSpPr/>
-        <p:nvPr/>
-      </p:nvGrpSpPr>
-      <p:grpSpPr/>
-      <p:sp>
-        <p:nvSpPr>
-          <p:cNvPr id="2" name="TextBox 1"/>
-          <p:cNvSpPr txBox="1"/>
-          <p:nvPr/>
-        </p:nvSpPr>
-        <p:spPr>
-          <a:xfrm>
-            <a:off x="320040" y="320040"/>
-            <a:ext cx="11430000" cy="502920"/>
-          </a:xfrm>
-          <a:prstGeom prst="rect">
-            <a:avLst/>
-          </a:prstGeom>
-          <a:noFill/>
-        </p:spPr>
-        <p:txBody>
-          <a:bodyPr wrap="square">
-            <a:spAutoFit/>
-          </a:bodyPr>
-          <a:lstStyle/>
-          <a:p>
-            <a:pPr algn="l"/>
-            <a:r>
-              <a:rPr sz="2400" b="1">
-                <a:solidFill>
-                  <a:srgbClr val="1F3864"/>
-                </a:solidFill>
-              </a:rPr>
-              <a:t>Three Metabolite Preprocessing Approaches</a:t>
-            </a:r>
-          </a:p>
-        </p:txBody>
-      </p:sp>
-      <p:sp>
-        <p:nvSpPr>
-          <p:cNvPr id="3" name="TextBox 2"/>
-          <p:cNvSpPr txBox="1"/>
-          <p:nvPr/>
-        </p:nvSpPr>
-        <p:spPr>
-          <a:xfrm>
-            <a:off x="320040" y="658368"/>
-            <a:ext cx="11430000" cy="5943600"/>
-          </a:xfrm>
-          <a:prstGeom prst="rect">
-            <a:avLst/>
-          </a:prstGeom>
-          <a:noFill/>
-        </p:spPr>
-        <p:txBody>
-          <a:bodyPr wrap="square">
-            <a:spAutoFit/>
-          </a:bodyPr>
-          <a:lstStyle/>
-          <a:p>
-            <a:pPr algn="l"/>
-            <a:r>
-              <a:rPr sz="1300" b="0">
-                <a:solidFill>
-                  <a:srgbClr val="000000"/>
-                </a:solidFill>
-              </a:rPr>
-              <a:t>Background
-  MalateGlo assay occasionally produces extreme negative concentrations (e.g. −5662 µM)
-  interpreted as assay failure. The original pipeline replaces values &lt; −500 µM with NaN.
-  This experiment tests whether that correction matters and whether MalateGlo adds value.
-Variant 1 — met_nan  (original)
-  Concentration values below −500 µM → NaN. LightGBM handles NaN natively.
-Variant 2 — met_raw
-  Raw concentration used as-is. No floor applied. Tests whether outlier flagging matters.
-Variant 3 — met_no_malate
-  MalateGlo feature excluded entirely (all 3 MalateGlo columns: concentration, initial,
-  growth rate). Tests whether MalateGlo adds discriminative signal.
-  Note: MalateGlo is only present for days &gt; Dy10 (conditional metabolite).
-All three variants are trained independently on the same fold splits in every repeat.
-Comparison is therefore perfectly controlled for cohort and fold assignments.</a:t>
-            </a:r>
-          </a:p>
-        </p:txBody>
-      </p:sp>
-    </p:spTree>
-  </p:cSld>
-  <p:clrMapOvr>
-    <a:masterClrMapping/>
-  </p:clrMapOvr>
-</p:sld>
-</file>
-
-<file path=ppt/slides/slide3.xml><?xml version="1.0" encoding="utf-8"?>
-<p:sld xmlns:a="http://schemas.openxmlformats.org/drawingml/2006/main" xmlns:p="http://schemas.openxmlformats.org/presentationml/2006/main" xmlns:r="http://schemas.openxmlformats.org/officeDocument/2006/relationships">
-  <p:cSld>
-    <p:spTree>
-      <p:nvGrpSpPr>
-        <p:cNvPr id="1" name=""/>
-        <p:cNvGrpSpPr/>
-        <p:nvPr/>
-      </p:nvGrpSpPr>
-      <p:grpSpPr/>
-      <p:sp>
-        <p:nvSpPr>
-          <p:cNvPr id="2" name="TextBox 1"/>
-          <p:cNvSpPr txBox="1"/>
-          <p:nvPr/>
-        </p:nvSpPr>
-        <p:spPr>
-          <a:xfrm>
-            <a:off x="320040" y="320040"/>
-            <a:ext cx="11430000" cy="502920"/>
-          </a:xfrm>
-          <a:prstGeom prst="rect">
-            <a:avLst/>
-          </a:prstGeom>
-          <a:noFill/>
-        </p:spPr>
-        <p:txBody>
-          <a:bodyPr wrap="square">
-            <a:spAutoFit/>
-          </a:bodyPr>
-          <a:lstStyle/>
-          <a:p>
-            <a:pPr algn="l"/>
-            <a:r>
-              <a:rPr sz="2200" b="1">
-                <a:solidFill>
-                  <a:srgbClr val="1F3864"/>
-                </a:solidFill>
-              </a:rPr>
-              <a:t>Standalone BA — 3 Met Variants</a:t>
-            </a:r>
-          </a:p>
-        </p:txBody>
-      </p:sp>
-      <p:pic>
-        <p:nvPicPr>
-          <p:cNvPr id="3" name="Picture 2" descr="image.png"/>
-          <p:cNvPicPr>
-            <a:picLocks noChangeAspect="1"/>
-          </p:cNvPicPr>
-          <p:nvPr/>
-        </p:nvPicPr>
-        <p:blipFill>
-          <a:blip r:embed="rId2"/>
-          <a:stretch>
-            <a:fillRect/>
-          </a:stretch>
-        </p:blipFill>
-        <p:spPr>
-          <a:xfrm>
-            <a:off x="320040" y="685800"/>
-            <a:ext cx="11430000" cy="4588788"/>
-          </a:xfrm>
-          <a:prstGeom prst="rect">
-            <a:avLst/>
-          </a:prstGeom>
-        </p:spPr>
-      </p:pic>
-    </p:spTree>
-  </p:cSld>
-  <p:clrMapOvr>
-    <a:masterClrMapping/>
-  </p:clrMapOvr>
-</p:sld>
-</file>
-
-<file path=ppt/slides/slide4.xml><?xml version="1.0" encoding="utf-8"?>
-<p:sld xmlns:a="http://schemas.openxmlformats.org/drawingml/2006/main" xmlns:p="http://schemas.openxmlformats.org/presentationml/2006/main" xmlns:r="http://schemas.openxmlformats.org/officeDocument/2006/relationships">
-  <p:cSld>
-    <p:spTree>
-      <p:nvGrpSpPr>
-        <p:cNvPr id="1" name=""/>
-        <p:cNvGrpSpPr/>
-        <p:nvPr/>
-      </p:nvGrpSpPr>
-      <p:grpSpPr/>
-      <p:sp>
-        <p:nvSpPr>
-          <p:cNvPr id="2" name="TextBox 1"/>
-          <p:cNvSpPr txBox="1"/>
-          <p:nvPr/>
-        </p:nvSpPr>
-        <p:spPr>
-          <a:xfrm>
-            <a:off x="320040" y="320040"/>
-            <a:ext cx="11430000" cy="502920"/>
-          </a:xfrm>
-          <a:prstGeom prst="rect">
-            <a:avLst/>
-          </a:prstGeom>
-          <a:noFill/>
-        </p:spPr>
-        <p:txBody>
-          <a:bodyPr wrap="square">
-            <a:spAutoFit/>
-          </a:bodyPr>
-          <a:lstStyle/>
-          <a:p>
-            <a:pPr algn="l"/>
-            <a:r>
-              <a:rPr sz="2200" b="1">
-                <a:solidFill>
-                  <a:srgbClr val="1F3864"/>
-                </a:solidFill>
-              </a:rPr>
-              <a:t>Late-Fusion BA — 3 Met Variants vs Morph+Img Baseline</a:t>
-            </a:r>
-          </a:p>
-        </p:txBody>
-      </p:sp>
-      <p:pic>
-        <p:nvPicPr>
-          <p:cNvPr id="3" name="Picture 2" descr="image.png"/>
-          <p:cNvPicPr>
-            <a:picLocks noChangeAspect="1"/>
-          </p:cNvPicPr>
-          <p:nvPr/>
-        </p:nvPicPr>
-        <p:blipFill>
-          <a:blip r:embed="rId2"/>
-          <a:stretch>
-            <a:fillRect/>
-          </a:stretch>
-        </p:blipFill>
-        <p:spPr>
-          <a:xfrm>
-            <a:off x="320040" y="685800"/>
-            <a:ext cx="11430000" cy="4588788"/>
-          </a:xfrm>
-          <a:prstGeom prst="rect">
-            <a:avLst/>
-          </a:prstGeom>
-        </p:spPr>
-      </p:pic>
-    </p:spTree>
-  </p:cSld>
-  <p:clrMapOvr>
-    <a:masterClrMapping/>
-  </p:clrMapOvr>
-</p:sld>
-</file>
-
-<file path=ppt/slides/slide5.xml><?xml version="1.0" encoding="utf-8"?>
-<p:sld xmlns:a="http://schemas.openxmlformats.org/drawingml/2006/main" xmlns:p="http://schemas.openxmlformats.org/presentationml/2006/main" xmlns:r="http://schemas.openxmlformats.org/officeDocument/2006/relationships">
-  <p:cSld>
-    <p:spTree>
-      <p:nvGrpSpPr>
-        <p:cNvPr id="1" name=""/>
-        <p:cNvGrpSpPr/>
-        <p:nvPr/>
-      </p:nvGrpSpPr>
-      <p:grpSpPr/>
-      <p:sp>
-        <p:nvSpPr>
-          <p:cNvPr id="2" name="TextBox 1"/>
-          <p:cNvSpPr txBox="1"/>
-          <p:nvPr/>
-        </p:nvSpPr>
-        <p:spPr>
-          <a:xfrm>
-            <a:off x="320040" y="320040"/>
-            <a:ext cx="11430000" cy="502920"/>
-          </a:xfrm>
-          <a:prstGeom prst="rect">
-            <a:avLst/>
-          </a:prstGeom>
-          <a:noFill/>
-        </p:spPr>
-        <p:txBody>
-          <a:bodyPr wrap="square">
-            <a:spAutoFit/>
-          </a:bodyPr>
-          <a:lstStyle/>
-          <a:p>
-            <a:pPr algn="l"/>
-            <a:r>
-              <a:rPr sz="2200" b="1">
-                <a:solidFill>
-                  <a:srgbClr val="1F3864"/>
-                </a:solidFill>
-              </a:rPr>
-              <a:t>Per-Day Differences Between Variants</a:t>
-            </a:r>
-          </a:p>
-        </p:txBody>
-      </p:sp>
-      <p:pic>
-        <p:nvPicPr>
-          <p:cNvPr id="3" name="Picture 2" descr="image.png"/>
-          <p:cNvPicPr>
-            <a:picLocks noChangeAspect="1"/>
-          </p:cNvPicPr>
-          <p:nvPr/>
-        </p:nvPicPr>
-        <p:blipFill>
-          <a:blip r:embed="rId2"/>
-          <a:stretch>
-            <a:fillRect/>
-          </a:stretch>
-        </p:blipFill>
-        <p:spPr>
-          <a:xfrm>
-            <a:off x="320040" y="685800"/>
-            <a:ext cx="11430000" cy="3516468"/>
-          </a:xfrm>
-          <a:prstGeom prst="rect">
-            <a:avLst/>
-          </a:prstGeom>
-        </p:spPr>
-      </p:pic>
-    </p:spTree>
-  </p:cSld>
-  <p:clrMapOvr>
-    <a:masterClrMapping/>
-  </p:clrMapOvr>
-</p:sld>
-</file>
-
-<file path=ppt/slides/slide6.xml><?xml version="1.0" encoding="utf-8"?>
-<p:sld xmlns:a="http://schemas.openxmlformats.org/drawingml/2006/main" xmlns:p="http://schemas.openxmlformats.org/presentationml/2006/main" xmlns:r="http://schemas.openxmlformats.org/officeDocument/2006/relationships">
-  <p:cSld>
-    <p:spTree>
-      <p:nvGrpSpPr>
-        <p:cNvPr id="1" name=""/>
-        <p:cNvGrpSpPr/>
-        <p:nvPr/>
-      </p:nvGrpSpPr>
-      <p:grpSpPr/>
-      <p:sp>
-        <p:nvSpPr>
-          <p:cNvPr id="2" name="TextBox 1"/>
-          <p:cNvSpPr txBox="1"/>
-          <p:nvPr/>
-        </p:nvSpPr>
-        <p:spPr>
-          <a:xfrm>
-            <a:off x="320040" y="320040"/>
-            <a:ext cx="11430000" cy="502920"/>
-          </a:xfrm>
-          <a:prstGeom prst="rect">
-            <a:avLst/>
-          </a:prstGeom>
-          <a:noFill/>
-        </p:spPr>
-        <p:txBody>
-          <a:bodyPr wrap="square">
-            <a:spAutoFit/>
-          </a:bodyPr>
-          <a:lstStyle/>
-          <a:p>
-            <a:pPr algn="l"/>
-            <a:r>
-              <a:rPr sz="2200" b="1">
-                <a:solidFill>
-                  <a:srgbClr val="1F3864"/>
-                </a:solidFill>
-              </a:rPr>
-              <a:t>Numeric Summary Table</a:t>
-            </a:r>
-          </a:p>
-        </p:txBody>
-      </p:sp>
-      <p:pic>
-        <p:nvPicPr>
-          <p:cNvPr id="3" name="Picture 2" descr="image.png"/>
-          <p:cNvPicPr>
-            <a:picLocks noChangeAspect="1"/>
-          </p:cNvPicPr>
-          <p:nvPr/>
-        </p:nvPicPr>
-        <p:blipFill>
-          <a:blip r:embed="rId2"/>
-          <a:stretch>
-            <a:fillRect/>
-          </a:stretch>
-        </p:blipFill>
-        <p:spPr>
-          <a:xfrm>
-            <a:off x="320040" y="640080"/>
-            <a:ext cx="11430000" cy="3320143"/>
-          </a:xfrm>
-          <a:prstGeom prst="rect">
-            <a:avLst/>
-          </a:prstGeom>
-        </p:spPr>
-      </p:pic>
-    </p:spTree>
-  </p:cSld>
-  <p:clrMapOvr>
-    <a:masterClrMapping/>
-  </p:clrMapOvr>
-</p:sld>
-</file>
-
-<file path=ppt/slides/slide7.xml><?xml version="1.0" encoding="utf-8"?>
-<p:sld xmlns:a="http://schemas.openxmlformats.org/drawingml/2006/main" xmlns:p="http://schemas.openxmlformats.org/presentationml/2006/main" xmlns:r="http://schemas.openxmlformats.org/officeDocument/2006/relationships">
-  <p:cSld>
-    <p:spTree>
-      <p:nvGrpSpPr>
-        <p:cNvPr id="1" name=""/>
-        <p:cNvGrpSpPr/>
-        <p:nvPr/>
-      </p:nvGrpSpPr>
-      <p:grpSpPr/>
-      <p:sp>
-        <p:nvSpPr>
-          <p:cNvPr id="2" name="TextBox 1"/>
-          <p:cNvSpPr txBox="1"/>
-          <p:nvPr/>
-        </p:nvSpPr>
-        <p:spPr>
-          <a:xfrm>
-            <a:off x="320040" y="320040"/>
-            <a:ext cx="11430000" cy="502920"/>
-          </a:xfrm>
-          <a:prstGeom prst="rect">
-            <a:avLst/>
-          </a:prstGeom>
-          <a:noFill/>
-        </p:spPr>
-        <p:txBody>
-          <a:bodyPr wrap="square">
-            <a:spAutoFit/>
-          </a:bodyPr>
-          <a:lstStyle/>
-          <a:p>
-            <a:pPr algn="l"/>
-            <a:r>
-              <a:rPr sz="2200" b="1">
-                <a:solidFill>
-                  <a:srgbClr val="1F3864"/>
-                </a:solidFill>
-              </a:rPr>
-              <a:t>Dy10 Experiment: Forcing MalateGlo In Where Outliers Live</a:t>
-            </a:r>
-          </a:p>
-        </p:txBody>
-      </p:sp>
-      <p:pic>
-        <p:nvPicPr>
-          <p:cNvPr id="3" name="Picture 2" descr="image.png"/>
-          <p:cNvPicPr>
-            <a:picLocks noChangeAspect="1"/>
-          </p:cNvPicPr>
-          <p:nvPr/>
-        </p:nvPicPr>
-        <p:blipFill>
-          <a:blip r:embed="rId2"/>
-          <a:stretch>
-            <a:fillRect/>
-          </a:stretch>
-        </p:blipFill>
-        <p:spPr>
-          <a:xfrm>
-            <a:off x="320040" y="658368"/>
-            <a:ext cx="7498079" cy="3339778"/>
-          </a:xfrm>
-          <a:prstGeom prst="rect">
-            <a:avLst/>
-          </a:prstGeom>
-        </p:spPr>
-      </p:pic>
-      <p:sp>
-        <p:nvSpPr>
-          <p:cNvPr id="4" name="TextBox 3"/>
-          <p:cNvSpPr txBox="1"/>
-          <p:nvPr/>
-        </p:nvSpPr>
-        <p:spPr>
-          <a:xfrm>
-            <a:off x="7955279" y="658368"/>
-            <a:ext cx="3931920" cy="5760720"/>
-          </a:xfrm>
-          <a:prstGeom prst="rect">
-            <a:avLst/>
-          </a:prstGeom>
-          <a:noFill/>
-        </p:spPr>
-        <p:txBody>
-          <a:bodyPr wrap="square">
-            <a:spAutoFit/>
-          </a:bodyPr>
-          <a:lstStyle/>
-          <a:p>
-            <a:pPr algn="l"/>
-            <a:r>
-              <a:rPr sz="1100" b="0">
-                <a:solidFill>
-                  <a:srgbClr val="000000"/>
-                </a:solidFill>
-              </a:rPr>
-              <a:t>Why this experiment?
-  Extreme MalateGlo values (e.g. −5662 µM) exist only at Dy10.
-  MalateGlo is normally excluded for days ≤ Dy10 (conditional metabolite),
-  so the floor correction never fires in the standard pipeline.
-  Here we force MalateGlo into Dy10 features to test the correction directly.
-Key findings
-  • nan vs raw: ~0.006–0.011 BA difference — floor correction works but
-    the effect is tiny, within repeat noise (±0.03–0.05 SD).
-  • LogReg: nan=0.613 &gt; drop/baseline=0.548 — gains most from keeping
-    MalateGlo (even with outliers replaced by NaN).
-  • LGBM/MLP: nan ≈ raw ≈ drop ≈ baseline — insensitive to MalateGlo at Dy10.
-  • SVM: stuck at 0.500 regardless — features not separable at Dy10.</a:t>
-            </a:r>
-          </a:p>
-        </p:txBody>
-      </p:sp>
-    </p:spTree>
-  </p:cSld>
-  <p:clrMapOvr>
-    <a:masterClrMapping/>
-  </p:clrMapOvr>
-</p:sld>
-</file>
-
-<file path=ppt/slides/slide8.xml><?xml version="1.0" encoding="utf-8"?>
+<file path=ppt/slides/slide10.xml><?xml version="1.0" encoding="utf-8"?>
 <p:sld xmlns:a="http://schemas.openxmlformats.org/drawingml/2006/main" xmlns:p="http://schemas.openxmlformats.org/presentationml/2006/main" xmlns:r="http://schemas.openxmlformats.org/officeDocument/2006/relationships">
   <p:cSld>
     <p:spTree>
@@ -3831,6 +3309,682 @@
           </a:p>
         </p:txBody>
       </p:sp>
+    </p:spTree>
+  </p:cSld>
+  <p:clrMapOvr>
+    <a:masterClrMapping/>
+  </p:clrMapOvr>
+</p:sld>
+</file>
+
+<file path=ppt/slides/slide2.xml><?xml version="1.0" encoding="utf-8"?>
+<p:sld xmlns:a="http://schemas.openxmlformats.org/drawingml/2006/main" xmlns:p="http://schemas.openxmlformats.org/presentationml/2006/main" xmlns:r="http://schemas.openxmlformats.org/officeDocument/2006/relationships">
+  <p:cSld>
+    <p:spTree>
+      <p:nvGrpSpPr>
+        <p:cNvPr id="1" name=""/>
+        <p:cNvGrpSpPr/>
+        <p:nvPr/>
+      </p:nvGrpSpPr>
+      <p:grpSpPr/>
+      <p:sp>
+        <p:nvSpPr>
+          <p:cNvPr id="2" name="TextBox 1"/>
+          <p:cNvSpPr txBox="1"/>
+          <p:nvPr/>
+        </p:nvSpPr>
+        <p:spPr>
+          <a:xfrm>
+            <a:off x="320040" y="320040"/>
+            <a:ext cx="11430000" cy="502920"/>
+          </a:xfrm>
+          <a:prstGeom prst="rect">
+            <a:avLst/>
+          </a:prstGeom>
+          <a:noFill/>
+        </p:spPr>
+        <p:txBody>
+          <a:bodyPr wrap="square">
+            <a:spAutoFit/>
+          </a:bodyPr>
+          <a:lstStyle/>
+          <a:p>
+            <a:pPr algn="l"/>
+            <a:r>
+              <a:rPr sz="2400" b="1">
+                <a:solidFill>
+                  <a:srgbClr val="1F3864"/>
+                </a:solidFill>
+              </a:rPr>
+              <a:t>Three Metabolite Preprocessing Approaches</a:t>
+            </a:r>
+          </a:p>
+        </p:txBody>
+      </p:sp>
+      <p:sp>
+        <p:nvSpPr>
+          <p:cNvPr id="3" name="TextBox 2"/>
+          <p:cNvSpPr txBox="1"/>
+          <p:nvPr/>
+        </p:nvSpPr>
+        <p:spPr>
+          <a:xfrm>
+            <a:off x="320040" y="658368"/>
+            <a:ext cx="11430000" cy="5943600"/>
+          </a:xfrm>
+          <a:prstGeom prst="rect">
+            <a:avLst/>
+          </a:prstGeom>
+          <a:noFill/>
+        </p:spPr>
+        <p:txBody>
+          <a:bodyPr wrap="square">
+            <a:spAutoFit/>
+          </a:bodyPr>
+          <a:lstStyle/>
+          <a:p>
+            <a:pPr algn="l"/>
+            <a:r>
+              <a:rPr sz="1300" b="0">
+                <a:solidFill>
+                  <a:srgbClr val="000000"/>
+                </a:solidFill>
+              </a:rPr>
+              <a:t>Background
+  MalateGlo assay occasionally produces extreme negative concentrations (e.g. −5662 µM)
+  interpreted as assay failure. The original pipeline replaces values &lt; −500 µM with NaN.
+  This experiment tests whether that correction matters and whether MalateGlo adds value.
+Variant 1 — met_nan  (original)
+  Concentration values below −500 µM → NaN. LightGBM handles NaN natively.
+Variant 2 — met_raw
+  Raw concentration used as-is. No floor applied. Tests whether outlier flagging matters.
+Variant 3 — met_no_malate
+  MalateGlo feature excluded entirely (all 3 MalateGlo columns: concentration, initial,
+  growth rate). Tests whether MalateGlo adds discriminative signal.
+  Note: MalateGlo is only present for days &gt; Dy10 (conditional metabolite).
+All three variants are trained independently on the same fold splits in every repeat.
+Comparison is therefore perfectly controlled for cohort and fold assignments.</a:t>
+            </a:r>
+          </a:p>
+        </p:txBody>
+      </p:sp>
+    </p:spTree>
+  </p:cSld>
+  <p:clrMapOvr>
+    <a:masterClrMapping/>
+  </p:clrMapOvr>
+</p:sld>
+</file>
+
+<file path=ppt/slides/slide3.xml><?xml version="1.0" encoding="utf-8"?>
+<p:sld xmlns:a="http://schemas.openxmlformats.org/drawingml/2006/main" xmlns:p="http://schemas.openxmlformats.org/presentationml/2006/main" xmlns:r="http://schemas.openxmlformats.org/officeDocument/2006/relationships">
+  <p:cSld>
+    <p:spTree>
+      <p:nvGrpSpPr>
+        <p:cNvPr id="1" name=""/>
+        <p:cNvGrpSpPr/>
+        <p:nvPr/>
+      </p:nvGrpSpPr>
+      <p:grpSpPr/>
+      <p:sp>
+        <p:nvSpPr>
+          <p:cNvPr id="2" name="TextBox 1"/>
+          <p:cNvSpPr txBox="1"/>
+          <p:nvPr/>
+        </p:nvSpPr>
+        <p:spPr>
+          <a:xfrm>
+            <a:off x="320040" y="320040"/>
+            <a:ext cx="11430000" cy="502920"/>
+          </a:xfrm>
+          <a:prstGeom prst="rect">
+            <a:avLst/>
+          </a:prstGeom>
+          <a:noFill/>
+        </p:spPr>
+        <p:txBody>
+          <a:bodyPr wrap="square">
+            <a:spAutoFit/>
+          </a:bodyPr>
+          <a:lstStyle/>
+          <a:p>
+            <a:pPr algn="l"/>
+            <a:r>
+              <a:rPr sz="2200" b="1">
+                <a:solidFill>
+                  <a:srgbClr val="1F3864"/>
+                </a:solidFill>
+              </a:rPr>
+              <a:t>Standalone BA — 3 Met Variants</a:t>
+            </a:r>
+          </a:p>
+        </p:txBody>
+      </p:sp>
+      <p:pic>
+        <p:nvPicPr>
+          <p:cNvPr id="3" name="Picture 2" descr="image.png"/>
+          <p:cNvPicPr>
+            <a:picLocks noChangeAspect="1"/>
+          </p:cNvPicPr>
+          <p:nvPr/>
+        </p:nvPicPr>
+        <p:blipFill>
+          <a:blip r:embed="rId2"/>
+          <a:stretch>
+            <a:fillRect/>
+          </a:stretch>
+        </p:blipFill>
+        <p:spPr>
+          <a:xfrm>
+            <a:off x="320040" y="685800"/>
+            <a:ext cx="11430000" cy="4588788"/>
+          </a:xfrm>
+          <a:prstGeom prst="rect">
+            <a:avLst/>
+          </a:prstGeom>
+        </p:spPr>
+      </p:pic>
+    </p:spTree>
+  </p:cSld>
+  <p:clrMapOvr>
+    <a:masterClrMapping/>
+  </p:clrMapOvr>
+</p:sld>
+</file>
+
+<file path=ppt/slides/slide4.xml><?xml version="1.0" encoding="utf-8"?>
+<p:sld xmlns:a="http://schemas.openxmlformats.org/drawingml/2006/main" xmlns:p="http://schemas.openxmlformats.org/presentationml/2006/main" xmlns:r="http://schemas.openxmlformats.org/officeDocument/2006/relationships">
+  <p:cSld>
+    <p:spTree>
+      <p:nvGrpSpPr>
+        <p:cNvPr id="1" name=""/>
+        <p:cNvGrpSpPr/>
+        <p:nvPr/>
+      </p:nvGrpSpPr>
+      <p:grpSpPr/>
+      <p:sp>
+        <p:nvSpPr>
+          <p:cNvPr id="2" name="TextBox 1"/>
+          <p:cNvSpPr txBox="1"/>
+          <p:nvPr/>
+        </p:nvSpPr>
+        <p:spPr>
+          <a:xfrm>
+            <a:off x="320040" y="320040"/>
+            <a:ext cx="11430000" cy="502920"/>
+          </a:xfrm>
+          <a:prstGeom prst="rect">
+            <a:avLst/>
+          </a:prstGeom>
+          <a:noFill/>
+        </p:spPr>
+        <p:txBody>
+          <a:bodyPr wrap="square">
+            <a:spAutoFit/>
+          </a:bodyPr>
+          <a:lstStyle/>
+          <a:p>
+            <a:pPr algn="l"/>
+            <a:r>
+              <a:rPr sz="2200" b="1">
+                <a:solidFill>
+                  <a:srgbClr val="1F3864"/>
+                </a:solidFill>
+              </a:rPr>
+              <a:t>Late-Fusion BA — 3 Met Variants vs Morph+Img Baseline</a:t>
+            </a:r>
+          </a:p>
+        </p:txBody>
+      </p:sp>
+      <p:pic>
+        <p:nvPicPr>
+          <p:cNvPr id="3" name="Picture 2" descr="image.png"/>
+          <p:cNvPicPr>
+            <a:picLocks noChangeAspect="1"/>
+          </p:cNvPicPr>
+          <p:nvPr/>
+        </p:nvPicPr>
+        <p:blipFill>
+          <a:blip r:embed="rId2"/>
+          <a:stretch>
+            <a:fillRect/>
+          </a:stretch>
+        </p:blipFill>
+        <p:spPr>
+          <a:xfrm>
+            <a:off x="320040" y="685800"/>
+            <a:ext cx="11430000" cy="4588788"/>
+          </a:xfrm>
+          <a:prstGeom prst="rect">
+            <a:avLst/>
+          </a:prstGeom>
+        </p:spPr>
+      </p:pic>
+    </p:spTree>
+  </p:cSld>
+  <p:clrMapOvr>
+    <a:masterClrMapping/>
+  </p:clrMapOvr>
+</p:sld>
+</file>
+
+<file path=ppt/slides/slide5.xml><?xml version="1.0" encoding="utf-8"?>
+<p:sld xmlns:a="http://schemas.openxmlformats.org/drawingml/2006/main" xmlns:p="http://schemas.openxmlformats.org/presentationml/2006/main" xmlns:r="http://schemas.openxmlformats.org/officeDocument/2006/relationships">
+  <p:cSld>
+    <p:spTree>
+      <p:nvGrpSpPr>
+        <p:cNvPr id="1" name=""/>
+        <p:cNvGrpSpPr/>
+        <p:nvPr/>
+      </p:nvGrpSpPr>
+      <p:grpSpPr/>
+      <p:sp>
+        <p:nvSpPr>
+          <p:cNvPr id="2" name="TextBox 1"/>
+          <p:cNvSpPr txBox="1"/>
+          <p:nvPr/>
+        </p:nvSpPr>
+        <p:spPr>
+          <a:xfrm>
+            <a:off x="320040" y="320040"/>
+            <a:ext cx="11430000" cy="502920"/>
+          </a:xfrm>
+          <a:prstGeom prst="rect">
+            <a:avLst/>
+          </a:prstGeom>
+          <a:noFill/>
+        </p:spPr>
+        <p:txBody>
+          <a:bodyPr wrap="square">
+            <a:spAutoFit/>
+          </a:bodyPr>
+          <a:lstStyle/>
+          <a:p>
+            <a:pPr algn="l"/>
+            <a:r>
+              <a:rPr sz="2200" b="1">
+                <a:solidFill>
+                  <a:srgbClr val="1F3864"/>
+                </a:solidFill>
+              </a:rPr>
+              <a:t>Per-Day Differences Between Variants</a:t>
+            </a:r>
+          </a:p>
+        </p:txBody>
+      </p:sp>
+      <p:pic>
+        <p:nvPicPr>
+          <p:cNvPr id="3" name="Picture 2" descr="image.png"/>
+          <p:cNvPicPr>
+            <a:picLocks noChangeAspect="1"/>
+          </p:cNvPicPr>
+          <p:nvPr/>
+        </p:nvPicPr>
+        <p:blipFill>
+          <a:blip r:embed="rId2"/>
+          <a:stretch>
+            <a:fillRect/>
+          </a:stretch>
+        </p:blipFill>
+        <p:spPr>
+          <a:xfrm>
+            <a:off x="320040" y="685800"/>
+            <a:ext cx="11430000" cy="3516468"/>
+          </a:xfrm>
+          <a:prstGeom prst="rect">
+            <a:avLst/>
+          </a:prstGeom>
+        </p:spPr>
+      </p:pic>
+    </p:spTree>
+  </p:cSld>
+  <p:clrMapOvr>
+    <a:masterClrMapping/>
+  </p:clrMapOvr>
+</p:sld>
+</file>
+
+<file path=ppt/slides/slide6.xml><?xml version="1.0" encoding="utf-8"?>
+<p:sld xmlns:a="http://schemas.openxmlformats.org/drawingml/2006/main" xmlns:p="http://schemas.openxmlformats.org/presentationml/2006/main" xmlns:r="http://schemas.openxmlformats.org/officeDocument/2006/relationships">
+  <p:cSld>
+    <p:spTree>
+      <p:nvGrpSpPr>
+        <p:cNvPr id="1" name=""/>
+        <p:cNvGrpSpPr/>
+        <p:nvPr/>
+      </p:nvGrpSpPr>
+      <p:grpSpPr/>
+      <p:sp>
+        <p:nvSpPr>
+          <p:cNvPr id="2" name="TextBox 1"/>
+          <p:cNvSpPr txBox="1"/>
+          <p:nvPr/>
+        </p:nvSpPr>
+        <p:spPr>
+          <a:xfrm>
+            <a:off x="320040" y="320040"/>
+            <a:ext cx="11430000" cy="502920"/>
+          </a:xfrm>
+          <a:prstGeom prst="rect">
+            <a:avLst/>
+          </a:prstGeom>
+          <a:noFill/>
+        </p:spPr>
+        <p:txBody>
+          <a:bodyPr wrap="square">
+            <a:spAutoFit/>
+          </a:bodyPr>
+          <a:lstStyle/>
+          <a:p>
+            <a:pPr algn="l"/>
+            <a:r>
+              <a:rPr sz="2200" b="1">
+                <a:solidFill>
+                  <a:srgbClr val="1F3864"/>
+                </a:solidFill>
+              </a:rPr>
+              <a:t>Numeric Summary Table</a:t>
+            </a:r>
+          </a:p>
+        </p:txBody>
+      </p:sp>
+      <p:pic>
+        <p:nvPicPr>
+          <p:cNvPr id="3" name="Picture 2" descr="image.png"/>
+          <p:cNvPicPr>
+            <a:picLocks noChangeAspect="1"/>
+          </p:cNvPicPr>
+          <p:nvPr/>
+        </p:nvPicPr>
+        <p:blipFill>
+          <a:blip r:embed="rId2"/>
+          <a:stretch>
+            <a:fillRect/>
+          </a:stretch>
+        </p:blipFill>
+        <p:spPr>
+          <a:xfrm>
+            <a:off x="320040" y="640080"/>
+            <a:ext cx="11430000" cy="3320143"/>
+          </a:xfrm>
+          <a:prstGeom prst="rect">
+            <a:avLst/>
+          </a:prstGeom>
+        </p:spPr>
+      </p:pic>
+    </p:spTree>
+  </p:cSld>
+  <p:clrMapOvr>
+    <a:masterClrMapping/>
+  </p:clrMapOvr>
+</p:sld>
+</file>
+
+<file path=ppt/slides/slide7.xml><?xml version="1.0" encoding="utf-8"?>
+<p:sld xmlns:a="http://schemas.openxmlformats.org/drawingml/2006/main" xmlns:p="http://schemas.openxmlformats.org/presentationml/2006/main" xmlns:r="http://schemas.openxmlformats.org/officeDocument/2006/relationships">
+  <p:cSld>
+    <p:spTree>
+      <p:nvGrpSpPr>
+        <p:cNvPr id="1" name=""/>
+        <p:cNvGrpSpPr/>
+        <p:nvPr/>
+      </p:nvGrpSpPr>
+      <p:grpSpPr/>
+      <p:sp>
+        <p:nvSpPr>
+          <p:cNvPr id="2" name="TextBox 1"/>
+          <p:cNvSpPr txBox="1"/>
+          <p:nvPr/>
+        </p:nvSpPr>
+        <p:spPr>
+          <a:xfrm>
+            <a:off x="320040" y="320040"/>
+            <a:ext cx="11430000" cy="502920"/>
+          </a:xfrm>
+          <a:prstGeom prst="rect">
+            <a:avLst/>
+          </a:prstGeom>
+          <a:noFill/>
+        </p:spPr>
+        <p:txBody>
+          <a:bodyPr wrap="square">
+            <a:spAutoFit/>
+          </a:bodyPr>
+          <a:lstStyle/>
+          <a:p>
+            <a:pPr algn="l"/>
+            <a:r>
+              <a:rPr sz="2200" b="1">
+                <a:solidFill>
+                  <a:srgbClr val="1F3864"/>
+                </a:solidFill>
+              </a:rPr>
+              <a:t>Dy10 Experiment: Forcing MalateGlo In Where Outliers Live</a:t>
+            </a:r>
+          </a:p>
+        </p:txBody>
+      </p:sp>
+      <p:pic>
+        <p:nvPicPr>
+          <p:cNvPr id="3" name="Picture 2" descr="image.png"/>
+          <p:cNvPicPr>
+            <a:picLocks noChangeAspect="1"/>
+          </p:cNvPicPr>
+          <p:nvPr/>
+        </p:nvPicPr>
+        <p:blipFill>
+          <a:blip r:embed="rId2"/>
+          <a:stretch>
+            <a:fillRect/>
+          </a:stretch>
+        </p:blipFill>
+        <p:spPr>
+          <a:xfrm>
+            <a:off x="320040" y="658368"/>
+            <a:ext cx="7498079" cy="3339778"/>
+          </a:xfrm>
+          <a:prstGeom prst="rect">
+            <a:avLst/>
+          </a:prstGeom>
+        </p:spPr>
+      </p:pic>
+      <p:sp>
+        <p:nvSpPr>
+          <p:cNvPr id="4" name="TextBox 3"/>
+          <p:cNvSpPr txBox="1"/>
+          <p:nvPr/>
+        </p:nvSpPr>
+        <p:spPr>
+          <a:xfrm>
+            <a:off x="7955279" y="658368"/>
+            <a:ext cx="3931920" cy="5760720"/>
+          </a:xfrm>
+          <a:prstGeom prst="rect">
+            <a:avLst/>
+          </a:prstGeom>
+          <a:noFill/>
+        </p:spPr>
+        <p:txBody>
+          <a:bodyPr wrap="square">
+            <a:spAutoFit/>
+          </a:bodyPr>
+          <a:lstStyle/>
+          <a:p>
+            <a:pPr algn="l"/>
+            <a:r>
+              <a:rPr sz="1100" b="0">
+                <a:solidFill>
+                  <a:srgbClr val="000000"/>
+                </a:solidFill>
+              </a:rPr>
+              <a:t>Why this experiment?
+  Extreme MalateGlo values (e.g. −5662 µM) exist only at Dy10.
+  MalateGlo is normally excluded for days ≤ Dy10 (conditional metabolite),
+  so the floor correction never fires in the standard pipeline.
+  Here we force MalateGlo into Dy10 features to test the correction directly.
+Key findings
+  • nan vs raw: ~0.006–0.011 BA difference — floor correction works but
+    the effect is tiny, within repeat noise (±0.03–0.05 SD).
+  • LogReg: nan=0.613 &gt; drop/baseline=0.548 — gains most from keeping
+    MalateGlo (even with outliers replaced by NaN).
+  • LGBM/MLP: nan ≈ raw ≈ drop ≈ baseline — insensitive to MalateGlo at Dy10.
+  • SVM: stuck at 0.500 regardless — features not separable at Dy10.</a:t>
+            </a:r>
+          </a:p>
+        </p:txBody>
+      </p:sp>
+    </p:spTree>
+  </p:cSld>
+  <p:clrMapOvr>
+    <a:masterClrMapping/>
+  </p:clrMapOvr>
+</p:sld>
+</file>
+
+<file path=ppt/slides/slide8.xml><?xml version="1.0" encoding="utf-8"?>
+<p:sld xmlns:a="http://schemas.openxmlformats.org/drawingml/2006/main" xmlns:p="http://schemas.openxmlformats.org/presentationml/2006/main" xmlns:r="http://schemas.openxmlformats.org/officeDocument/2006/relationships">
+  <p:cSld>
+    <p:spTree>
+      <p:nvGrpSpPr>
+        <p:cNvPr id="1" name=""/>
+        <p:cNvGrpSpPr/>
+        <p:nvPr/>
+      </p:nvGrpSpPr>
+      <p:grpSpPr/>
+      <p:sp>
+        <p:nvSpPr>
+          <p:cNvPr id="2" name="TextBox 1"/>
+          <p:cNvSpPr txBox="1"/>
+          <p:nvPr/>
+        </p:nvSpPr>
+        <p:spPr>
+          <a:xfrm>
+            <a:off x="320040" y="320040"/>
+            <a:ext cx="11430000" cy="502920"/>
+          </a:xfrm>
+          <a:prstGeom prst="rect">
+            <a:avLst/>
+          </a:prstGeom>
+          <a:noFill/>
+        </p:spPr>
+        <p:txBody>
+          <a:bodyPr wrap="square">
+            <a:spAutoFit/>
+          </a:bodyPr>
+          <a:lstStyle/>
+          <a:p>
+            <a:pPr algn="l"/>
+            <a:r>
+              <a:rPr sz="2200" b="1">
+                <a:solidFill>
+                  <a:srgbClr val="1F3864"/>
+                </a:solidFill>
+              </a:rPr>
+              <a:t>Confusion Matrices — 4 Classifiers × Key Days (met_nan, aggregated 10 repeats)</a:t>
+            </a:r>
+          </a:p>
+        </p:txBody>
+      </p:sp>
+      <p:pic>
+        <p:nvPicPr>
+          <p:cNvPr id="3" name="Picture 2" descr="image.png"/>
+          <p:cNvPicPr>
+            <a:picLocks noChangeAspect="1"/>
+          </p:cNvPicPr>
+          <p:nvPr/>
+        </p:nvPicPr>
+        <p:blipFill>
+          <a:blip r:embed="rId2"/>
+          <a:stretch>
+            <a:fillRect/>
+          </a:stretch>
+        </p:blipFill>
+        <p:spPr>
+          <a:xfrm>
+            <a:off x="320040" y="658368"/>
+            <a:ext cx="11430000" cy="13290698"/>
+          </a:xfrm>
+          <a:prstGeom prst="rect">
+            <a:avLst/>
+          </a:prstGeom>
+        </p:spPr>
+      </p:pic>
+    </p:spTree>
+  </p:cSld>
+  <p:clrMapOvr>
+    <a:masterClrMapping/>
+  </p:clrMapOvr>
+</p:sld>
+</file>
+
+<file path=ppt/slides/slide9.xml><?xml version="1.0" encoding="utf-8"?>
+<p:sld xmlns:a="http://schemas.openxmlformats.org/drawingml/2006/main" xmlns:p="http://schemas.openxmlformats.org/presentationml/2006/main" xmlns:r="http://schemas.openxmlformats.org/officeDocument/2006/relationships">
+  <p:cSld>
+    <p:spTree>
+      <p:nvGrpSpPr>
+        <p:cNvPr id="1" name=""/>
+        <p:cNvGrpSpPr/>
+        <p:nvPr/>
+      </p:nvGrpSpPr>
+      <p:grpSpPr/>
+      <p:sp>
+        <p:nvSpPr>
+          <p:cNvPr id="2" name="TextBox 1"/>
+          <p:cNvSpPr txBox="1"/>
+          <p:nvPr/>
+        </p:nvSpPr>
+        <p:spPr>
+          <a:xfrm>
+            <a:off x="320040" y="320040"/>
+            <a:ext cx="11430000" cy="502920"/>
+          </a:xfrm>
+          <a:prstGeom prst="rect">
+            <a:avLst/>
+          </a:prstGeom>
+          <a:noFill/>
+        </p:spPr>
+        <p:txBody>
+          <a:bodyPr wrap="square">
+            <a:spAutoFit/>
+          </a:bodyPr>
+          <a:lstStyle/>
+          <a:p>
+            <a:pPr algn="l"/>
+            <a:r>
+              <a:rPr sz="2200" b="1">
+                <a:solidFill>
+                  <a:srgbClr val="1F3864"/>
+                </a:solidFill>
+              </a:rPr>
+              <a:t>Malate Variant Effect on Confusion Matrix — LogReg at Dy30</a:t>
+            </a:r>
+          </a:p>
+        </p:txBody>
+      </p:sp>
+      <p:pic>
+        <p:nvPicPr>
+          <p:cNvPr id="3" name="Picture 2" descr="image.png"/>
+          <p:cNvPicPr>
+            <a:picLocks noChangeAspect="1"/>
+          </p:cNvPicPr>
+          <p:nvPr/>
+        </p:nvPicPr>
+        <p:blipFill>
+          <a:blip r:embed="rId2"/>
+          <a:stretch>
+            <a:fillRect/>
+          </a:stretch>
+        </p:blipFill>
+        <p:spPr>
+          <a:xfrm>
+            <a:off x="320040" y="1645920"/>
+            <a:ext cx="9144000" cy="3254889"/>
+          </a:xfrm>
+          <a:prstGeom prst="rect">
+            <a:avLst/>
+          </a:prstGeom>
+        </p:spPr>
+      </p:pic>
     </p:spTree>
   </p:cSld>
   <p:clrMapOvr>

</xml_diff>